<commit_message>
Say "share of assault incidents", not "share of victims", for the partner statistic
The P0341 report (Figure 64) gives the percentage of assault *incidents*
committed by a spouse or intimate partner, by the victim's sex: 31.4% of
incidents against women, 2.2% against men. Stats SA's data-story article
phrased it as "female victims", and the dashboard and downloadable deck
repeated that looser wording. Someone assaulted twice counts twice, so
it is not a share of people. Wording corrected on the dashboard card and
KPI, and on the partner slide, footer and speaker notes of the deck.

Co-Authored-By: Claude Sonnet 5.5 <noreply@anthropic.com>
</commit_message>
<xml_diff>
--- a/docs/crime-in-south-africa.pptx
+++ b/docs/crime-in-south-africa.pptx
@@ -4381,7 +4381,7 @@
           <a:p>
             <a:r>
               <a:rPr lang="en-US" dirty="0"/>
-              <a:t>Of assault victims in 2025/26, 31.4% of women said the attacker was a spouse or intimate partner, compared with 2.2% of men: roughly a 14-fold difference in that share. It is a share of victims, not a rate per population, so it does not say that women are assaulted more often. The previous slide shows men are assaulted more often overall.</a:t>
+              <a:t>In 2025/26, 31.4% of assault incidents against women were committed by a spouse or intimate partner, compared with 2.2% of incidents against men (Stats SA P0341, Figure 64): roughly a 14-fold difference in that share. It is a share of incidents, not of people, and not a rate per population, so it does not say that women are assaulted more often. The previous slide shows men are assaulted more often overall.</a:t>
             </a:r>
             <a:endParaRPr lang="en-US" dirty="0"/>
           </a:p>
@@ -11067,7 +11067,7 @@
                 <a:ea typeface="Arial" pitchFamily="34" charset="-122"/>
                 <a:cs typeface="Arial" pitchFamily="34" charset="-120"/>
               </a:rPr>
-              <a:t>WOMEN’S ATTACKERS ARE FAR MORE OFTEN PARTNERS</a:t>
+              <a:t>FAR MORE ASSAULTS ON WOMEN ARE BY A PARTNER</a:t>
             </a:r>
             <a:endParaRPr lang="en-US" sz="3200" dirty="0"/>
           </a:p>
@@ -11172,7 +11172,7 @@
                 <a:ea typeface="Arial" pitchFamily="34" charset="-122"/>
                 <a:cs typeface="Arial" pitchFamily="34" charset="-120"/>
               </a:rPr>
-              <a:t>of women who were assaulted named a spouse or partner</a:t>
+              <a:t>of assaults on women were by a spouse or partner</a:t>
             </a:r>
             <a:endParaRPr lang="en-US" sz="1500" dirty="0"/>
           </a:p>
@@ -13777,7 +13777,7 @@
                 <a:ea typeface="Arial" pitchFamily="34" charset="-122"/>
                 <a:cs typeface="Arial" pitchFamily="34" charset="-120"/>
               </a:rPr>
-              <a:t>of men who were assaulted named a spouse or partner</a:t>
+              <a:t>of assaults on men were by a spouse or partner</a:t>
             </a:r>
             <a:endParaRPr lang="en-US" sz="1500" dirty="0"/>
           </a:p>
@@ -16316,7 +16316,7 @@
                 <a:ea typeface="Arial" pitchFamily="34" charset="-122"/>
                 <a:cs typeface="Arial" pitchFamily="34" charset="-120"/>
               </a:rPr>
-              <a:t>Men are assaulted more often overall, but women’s assaults are far more likely to involve someone close to them. Each dot is 1% of assault victims.</a:t>
+              <a:t>Men are assaulted more often overall, but women’s assaults are far more likely to involve someone close to them. Each dot is 1% of assault incidents.</a:t>
             </a:r>
             <a:endParaRPr lang="en-US" sz="1400" dirty="0"/>
           </a:p>
@@ -16355,7 +16355,7 @@
                 <a:ea typeface="Arial" pitchFamily="34" charset="-122"/>
                 <a:cs typeface="Arial" pitchFamily="34" charset="-120"/>
               </a:rPr>
-              <a:t>Source: Stats SA Victims of Crime Survey 2025/26  ·  relationship of attacker to victim, assault victims</a:t>
+              <a:t>Source: Stats SA Victims of Crime Survey 2025/26  ·  perpetrators of assault incidents, by victim’s sex</a:t>
             </a:r>
             <a:endParaRPr lang="en-US" sz="1200" dirty="0"/>
           </a:p>

</xml_diff>